<commit_message>
Finalise presentation: logged-in screenshots, condensed deck, presenter details
- Recapture UI screenshots signed-in via Playwright + real Chrome (live user,
  SSE efficiency and live API KPIs/alerts instead of Guest/offline)
- Refactor rendering into docs/pptx_common.py; make cover name/UID/date
  configurable via SMM_NAME / SMM_UID / SMM_DATE env vars
- Add condensed 10-slide deck (docs/Smart_Paper_Mill_Presentation_Short.pptx)
- Rebuild both decks with presenter details (Manreet Gill, 24BCS10479, June 2026)

Co-Authored-By: Claude Opus 4.8 <noreply@anthropic.com>
</commit_message>
<xml_diff>
--- a/docs/Smart_Paper_Mill_Presentation.pptx
+++ b/docs/Smart_Paper_Mill_Presentation.pptx
@@ -5311,7 +5311,7 @@
                 </a:solidFill>
                 <a:latin typeface="Calibri"/>
               </a:rPr>
-              <a:t>INDUSTRIAL TRAINING PROJECT  -  2026</a:t>
+              <a:t>INDUSTRIAL TRAINING PROJECT</a:t>
             </a:r>
           </a:p>
         </p:txBody>
@@ -5544,7 +5544,7 @@
                 </a:solidFill>
                 <a:latin typeface="Calibri"/>
               </a:rPr>
-              <a:t>[STUDENT NAME]   (UID: [____________])</a:t>
+              <a:t>Manreet Gill   (UID: 24BCS10479)</a:t>
             </a:r>
           </a:p>
           <a:p>
@@ -5607,7 +5607,7 @@
                 </a:solidFill>
                 <a:latin typeface="Calibri"/>
               </a:rPr>
-              <a:t>[MONTH] [YEAR]</a:t>
+              <a:t>June 2026</a:t>
             </a:r>
           </a:p>
         </p:txBody>
@@ -12862,7 +12862,7 @@
                 </a:solidFill>
                 <a:latin typeface="Calibri"/>
               </a:rPr>
-              <a:t>[STUDENT NAME]  -  B.E. CSE, Chandigarh University</a:t>
+              <a:t>Manreet Gill  -  B.E. CSE, Chandigarh University</a:t>
             </a:r>
           </a:p>
           <a:p>

</xml_diff>